<commit_message>
figure upgrade ,better calculation
</commit_message>
<xml_diff>
--- a/claude work/output/presentation.pptx
+++ b/claude work/output/presentation.pptx
@@ -2038,7 +2038,7 @@
                 <a:ea typeface="Calibri" pitchFamily="34" charset="-122"/>
                 <a:cs typeface="Calibri" pitchFamily="34" charset="-120"/>
               </a:rPr>
-              <a:t>Shannon entropy increases by +0.030 nats/month in high-propensity fields post-4o (p = 0.005)</a:t>
+              <a:t>Shannon entropy increases by +0.030 nats/month in high-propensity fields post-4o (p = 0.006)</a:t>
             </a:r>
             <a:endParaRPr lang="en-US" sz="1200" dirty="0"/>
           </a:p>
@@ -2781,7 +2781,7 @@
                 <a:ea typeface="Calibri" pitchFamily="34" charset="-122"/>
                 <a:cs typeface="Calibri" pitchFamily="34" charset="-120"/>
               </a:rPr>
-              <a:t>67,008 papers from OpenAlex (Jan 2021 – Dec 2025)</a:t>
+              <a:t>35,080 papers from OpenAlex (May 2023 – Dec 2025)</a:t>
             </a:r>
             <a:endParaRPr lang="en-US" sz="1800" dirty="0"/>
           </a:p>

</xml_diff>